<commit_message>
t - Commented GitLatch Commit @ 2024-7-2-11-50-5-581
</commit_message>
<xml_diff>
--- a/june25.pptx
+++ b/june25.pptx
@@ -270,7 +270,7 @@
           <a:p>
             <a:fld id="{F465A414-5ADB-4178-BBB9-F6D5CBEA4350}" type="datetimeFigureOut">
               <a:rPr lang="en-US" smtClean="0"/>
-              <a:t>6/26/2024</a:t>
+              <a:t>7/2/2024</a:t>
             </a:fld>
             <a:endParaRPr lang="en-US"/>
           </a:p>
@@ -468,7 +468,7 @@
           <a:p>
             <a:fld id="{F465A414-5ADB-4178-BBB9-F6D5CBEA4350}" type="datetimeFigureOut">
               <a:rPr lang="en-US" smtClean="0"/>
-              <a:t>6/26/2024</a:t>
+              <a:t>7/2/2024</a:t>
             </a:fld>
             <a:endParaRPr lang="en-US"/>
           </a:p>
@@ -676,7 +676,7 @@
           <a:p>
             <a:fld id="{F465A414-5ADB-4178-BBB9-F6D5CBEA4350}" type="datetimeFigureOut">
               <a:rPr lang="en-US" smtClean="0"/>
-              <a:t>6/26/2024</a:t>
+              <a:t>7/2/2024</a:t>
             </a:fld>
             <a:endParaRPr lang="en-US"/>
           </a:p>
@@ -874,7 +874,7 @@
           <a:p>
             <a:fld id="{F465A414-5ADB-4178-BBB9-F6D5CBEA4350}" type="datetimeFigureOut">
               <a:rPr lang="en-US" smtClean="0"/>
-              <a:t>6/26/2024</a:t>
+              <a:t>7/2/2024</a:t>
             </a:fld>
             <a:endParaRPr lang="en-US"/>
           </a:p>
@@ -1149,7 +1149,7 @@
           <a:p>
             <a:fld id="{F465A414-5ADB-4178-BBB9-F6D5CBEA4350}" type="datetimeFigureOut">
               <a:rPr lang="en-US" smtClean="0"/>
-              <a:t>6/26/2024</a:t>
+              <a:t>7/2/2024</a:t>
             </a:fld>
             <a:endParaRPr lang="en-US"/>
           </a:p>
@@ -1414,7 +1414,7 @@
           <a:p>
             <a:fld id="{F465A414-5ADB-4178-BBB9-F6D5CBEA4350}" type="datetimeFigureOut">
               <a:rPr lang="en-US" smtClean="0"/>
-              <a:t>6/26/2024</a:t>
+              <a:t>7/2/2024</a:t>
             </a:fld>
             <a:endParaRPr lang="en-US"/>
           </a:p>
@@ -1826,7 +1826,7 @@
           <a:p>
             <a:fld id="{F465A414-5ADB-4178-BBB9-F6D5CBEA4350}" type="datetimeFigureOut">
               <a:rPr lang="en-US" smtClean="0"/>
-              <a:t>6/26/2024</a:t>
+              <a:t>7/2/2024</a:t>
             </a:fld>
             <a:endParaRPr lang="en-US"/>
           </a:p>
@@ -1967,7 +1967,7 @@
           <a:p>
             <a:fld id="{F465A414-5ADB-4178-BBB9-F6D5CBEA4350}" type="datetimeFigureOut">
               <a:rPr lang="en-US" smtClean="0"/>
-              <a:t>6/26/2024</a:t>
+              <a:t>7/2/2024</a:t>
             </a:fld>
             <a:endParaRPr lang="en-US"/>
           </a:p>
@@ -2080,7 +2080,7 @@
           <a:p>
             <a:fld id="{F465A414-5ADB-4178-BBB9-F6D5CBEA4350}" type="datetimeFigureOut">
               <a:rPr lang="en-US" smtClean="0"/>
-              <a:t>6/26/2024</a:t>
+              <a:t>7/2/2024</a:t>
             </a:fld>
             <a:endParaRPr lang="en-US"/>
           </a:p>
@@ -2391,7 +2391,7 @@
           <a:p>
             <a:fld id="{F465A414-5ADB-4178-BBB9-F6D5CBEA4350}" type="datetimeFigureOut">
               <a:rPr lang="en-US" smtClean="0"/>
-              <a:t>6/26/2024</a:t>
+              <a:t>7/2/2024</a:t>
             </a:fld>
             <a:endParaRPr lang="en-US"/>
           </a:p>
@@ -2682,7 +2682,7 @@
           <a:p>
             <a:fld id="{F465A414-5ADB-4178-BBB9-F6D5CBEA4350}" type="datetimeFigureOut">
               <a:rPr lang="en-US" smtClean="0"/>
-              <a:t>6/26/2024</a:t>
+              <a:t>7/2/2024</a:t>
             </a:fld>
             <a:endParaRPr lang="en-US"/>
           </a:p>
@@ -2923,7 +2923,7 @@
           <a:p>
             <a:fld id="{F465A414-5ADB-4178-BBB9-F6D5CBEA4350}" type="datetimeFigureOut">
               <a:rPr lang="en-US" smtClean="0"/>
-              <a:t>6/26/2024</a:t>
+              <a:t>7/2/2024</a:t>
             </a:fld>
             <a:endParaRPr lang="en-US"/>
           </a:p>
@@ -3363,7 +3363,7 @@
           <a:p>
             <a:r>
               <a:rPr lang="en-IN"/>
-              <a:t>NEWTestest12122222222222222</a:t>
+              <a:t>NEWTestest121222222222222227777</a:t>
             </a:r>
             <a:endParaRPr lang="en-US" dirty="0"/>
           </a:p>
@@ -3749,7 +3749,7 @@
 
 <file path=ppt/webextensions/taskpanes.xml><?xml version="1.0" encoding="utf-8"?>
 <wetp:taskpanes xmlns:wetp="http://schemas.microsoft.com/office/webextensions/taskpanes/2010/11">
-  <wetp:taskpane dockstate="right" visibility="0" width="438" row="2">
+  <wetp:taskpane dockstate="right" visibility="0" width="525" row="2">
     <wetp:webextensionref xmlns:r="http://schemas.openxmlformats.org/officeDocument/2006/relationships" r:id="rId1"/>
   </wetp:taskpane>
 </wetp:taskpanes>

</xml_diff>

<commit_message>
BBBBBBB - Commented GitLatch Commit @ 2024-7-2-12-12-13-919
</commit_message>
<xml_diff>
--- a/june25.pptx
+++ b/june25.pptx
@@ -118,9 +118,47 @@
 <file path=ppt/revisionInfo.xml><?xml version="1.0" encoding="utf-8"?>
 <p1510:revInfo xmlns:a="http://schemas.openxmlformats.org/drawingml/2006/main" xmlns:r="http://schemas.openxmlformats.org/officeDocument/2006/relationships" xmlns:p1510="http://schemas.microsoft.com/office/powerpoint/2015/10/main">
   <p1510:revLst>
-    <p1510:client id="{F5CFAC46-907D-9E47-6EB4-26E74B892FBC}" v="87" dt="2024-06-25T09:57:32.581"/>
+    <p1510:client id="{5BE82309-CE73-145B-698D-BB721F153A9B}" v="7" dt="2024-07-02T12:12:07.843"/>
   </p1510:revLst>
 </p1510:revInfo>
+</file>
+
+<file path=ppt/changesInfos/changesInfo1.xml><?xml version="1.0" encoding="utf-8"?>
+<pc:chgInfo xmlns:a="http://schemas.openxmlformats.org/drawingml/2006/main" xmlns:r="http://schemas.openxmlformats.org/officeDocument/2006/relationships" xmlns:ac="http://schemas.microsoft.com/office/drawing/2013/main/command" xmlns:pc="http://schemas.microsoft.com/office/powerpoint/2013/main/command">
+  <pc:docChgLst>
+    <pc:chgData name="TEST_TEST_E3_SharedHb_202406260448_sQO3jLNdvw" userId="S::admin@a830edad9050849manzaapjiwha.onmicrosoft.com::f6dff790-a06c-4b8a-b5cb-4daa4367eac0" providerId="AD" clId="Web-{5BE82309-CE73-145B-698D-BB721F153A9B}"/>
+    <pc:docChg chg="replTag">
+      <pc:chgData name="TEST_TEST_E3_SharedHb_202406260448_sQO3jLNdvw" userId="S::admin@a830edad9050849manzaapjiwha.onmicrosoft.com::f6dff790-a06c-4b8a-b5cb-4daa4367eac0" providerId="AD" clId="Web-{5BE82309-CE73-145B-698D-BB721F153A9B}" dt="2024-07-02T12:12:07.843" v="5"/>
+      <pc:docMkLst>
+        <pc:docMk/>
+      </pc:docMkLst>
+    </pc:docChg>
+  </pc:docChgLst>
+  <pc:docChgLst>
+    <pc:chgData clId="Web-{5BE82309-CE73-145B-698D-BB721F153A9B}"/>
+    <pc:docChg chg="modSld">
+      <pc:chgData name="" userId="" providerId="" clId="Web-{5BE82309-CE73-145B-698D-BB721F153A9B}" dt="2024-07-02T12:11:43.185" v="0" actId="20577"/>
+      <pc:docMkLst>
+        <pc:docMk/>
+      </pc:docMkLst>
+      <pc:sldChg chg="modSp">
+        <pc:chgData name="" userId="" providerId="" clId="Web-{5BE82309-CE73-145B-698D-BB721F153A9B}" dt="2024-07-02T12:11:43.185" v="0" actId="20577"/>
+        <pc:sldMkLst>
+          <pc:docMk/>
+          <pc:sldMk cId="1155956452" sldId="256"/>
+        </pc:sldMkLst>
+        <pc:spChg chg="mod">
+          <ac:chgData name="" userId="" providerId="" clId="Web-{5BE82309-CE73-145B-698D-BB721F153A9B}" dt="2024-07-02T12:11:43.185" v="0" actId="20577"/>
+          <ac:spMkLst>
+            <pc:docMk/>
+            <pc:sldMk cId="1155956452" sldId="256"/>
+            <ac:spMk id="2" creationId="{2C77BA99-ADAA-7E6B-E5C0-0B85947EBB5F}"/>
+          </ac:spMkLst>
+        </pc:spChg>
+      </pc:sldChg>
+    </pc:docChg>
+  </pc:docChgLst>
+</pc:chgInfo>
 </file>
 
 <file path=ppt/slideLayouts/slideLayout1.xml><?xml version="1.0" encoding="utf-8"?>
@@ -3363,7 +3401,7 @@
           <a:p>
             <a:r>
               <a:rPr lang="en-IN"/>
-              <a:t>NEWTestest121222222222222227777888</a:t>
+              <a:t>NEWTestest12122222222222222777788888</a:t>
             </a:r>
             <a:endParaRPr lang="en-US" dirty="0"/>
           </a:p>

</xml_diff>

<commit_message>
AAAAAAAA - Commented GitLatch Commit @ 2024-7-2-18-1-58-463
</commit_message>
<xml_diff>
--- a/june25.pptx
+++ b/june25.pptx
@@ -123,44 +123,6 @@
 </p1510:revInfo>
 </file>
 
-<file path=ppt/changesInfos/changesInfo1.xml><?xml version="1.0" encoding="utf-8"?>
-<pc:chgInfo xmlns:a="http://schemas.openxmlformats.org/drawingml/2006/main" xmlns:r="http://schemas.openxmlformats.org/officeDocument/2006/relationships" xmlns:ac="http://schemas.microsoft.com/office/drawing/2013/main/command" xmlns:pc="http://schemas.microsoft.com/office/powerpoint/2013/main/command">
-  <pc:docChgLst>
-    <pc:chgData name="TEST_TEST_E3_SharedHb_202406260448_sQO3jLNdvw" userId="S::admin@a830edad9050849manzaapjiwha.onmicrosoft.com::f6dff790-a06c-4b8a-b5cb-4daa4367eac0" providerId="AD" clId="Web-{5BE82309-CE73-145B-698D-BB721F153A9B}"/>
-    <pc:docChg chg="replTag">
-      <pc:chgData name="TEST_TEST_E3_SharedHb_202406260448_sQO3jLNdvw" userId="S::admin@a830edad9050849manzaapjiwha.onmicrosoft.com::f6dff790-a06c-4b8a-b5cb-4daa4367eac0" providerId="AD" clId="Web-{5BE82309-CE73-145B-698D-BB721F153A9B}" dt="2024-07-02T12:12:07.843" v="5"/>
-      <pc:docMkLst>
-        <pc:docMk/>
-      </pc:docMkLst>
-    </pc:docChg>
-  </pc:docChgLst>
-  <pc:docChgLst>
-    <pc:chgData clId="Web-{5BE82309-CE73-145B-698D-BB721F153A9B}"/>
-    <pc:docChg chg="modSld">
-      <pc:chgData name="" userId="" providerId="" clId="Web-{5BE82309-CE73-145B-698D-BB721F153A9B}" dt="2024-07-02T12:11:43.185" v="0" actId="20577"/>
-      <pc:docMkLst>
-        <pc:docMk/>
-      </pc:docMkLst>
-      <pc:sldChg chg="modSp">
-        <pc:chgData name="" userId="" providerId="" clId="Web-{5BE82309-CE73-145B-698D-BB721F153A9B}" dt="2024-07-02T12:11:43.185" v="0" actId="20577"/>
-        <pc:sldMkLst>
-          <pc:docMk/>
-          <pc:sldMk cId="1155956452" sldId="256"/>
-        </pc:sldMkLst>
-        <pc:spChg chg="mod">
-          <ac:chgData name="" userId="" providerId="" clId="Web-{5BE82309-CE73-145B-698D-BB721F153A9B}" dt="2024-07-02T12:11:43.185" v="0" actId="20577"/>
-          <ac:spMkLst>
-            <pc:docMk/>
-            <pc:sldMk cId="1155956452" sldId="256"/>
-            <ac:spMk id="2" creationId="{2C77BA99-ADAA-7E6B-E5C0-0B85947EBB5F}"/>
-          </ac:spMkLst>
-        </pc:spChg>
-      </pc:sldChg>
-    </pc:docChg>
-  </pc:docChgLst>
-</pc:chgInfo>
-</file>
-
 <file path=ppt/slideLayouts/slideLayout1.xml><?xml version="1.0" encoding="utf-8"?>
 <p:sldLayout xmlns:a="http://schemas.openxmlformats.org/drawingml/2006/main" xmlns:r="http://schemas.openxmlformats.org/officeDocument/2006/relationships" xmlns:p="http://schemas.openxmlformats.org/presentationml/2006/main" type="title" preserve="1">
   <p:cSld name="Title Slide">
@@ -308,7 +270,7 @@
           <a:p>
             <a:fld id="{F465A414-5ADB-4178-BBB9-F6D5CBEA4350}" type="datetimeFigureOut">
               <a:rPr lang="en-US" smtClean="0"/>
-              <a:t>7/2/2024</a:t>
+              <a:t>7/2/24</a:t>
             </a:fld>
             <a:endParaRPr lang="en-US"/>
           </a:p>
@@ -506,7 +468,7 @@
           <a:p>
             <a:fld id="{F465A414-5ADB-4178-BBB9-F6D5CBEA4350}" type="datetimeFigureOut">
               <a:rPr lang="en-US" smtClean="0"/>
-              <a:t>7/2/2024</a:t>
+              <a:t>7/2/24</a:t>
             </a:fld>
             <a:endParaRPr lang="en-US"/>
           </a:p>
@@ -714,7 +676,7 @@
           <a:p>
             <a:fld id="{F465A414-5ADB-4178-BBB9-F6D5CBEA4350}" type="datetimeFigureOut">
               <a:rPr lang="en-US" smtClean="0"/>
-              <a:t>7/2/2024</a:t>
+              <a:t>7/2/24</a:t>
             </a:fld>
             <a:endParaRPr lang="en-US"/>
           </a:p>
@@ -912,7 +874,7 @@
           <a:p>
             <a:fld id="{F465A414-5ADB-4178-BBB9-F6D5CBEA4350}" type="datetimeFigureOut">
               <a:rPr lang="en-US" smtClean="0"/>
-              <a:t>7/2/2024</a:t>
+              <a:t>7/2/24</a:t>
             </a:fld>
             <a:endParaRPr lang="en-US"/>
           </a:p>
@@ -1187,7 +1149,7 @@
           <a:p>
             <a:fld id="{F465A414-5ADB-4178-BBB9-F6D5CBEA4350}" type="datetimeFigureOut">
               <a:rPr lang="en-US" smtClean="0"/>
-              <a:t>7/2/2024</a:t>
+              <a:t>7/2/24</a:t>
             </a:fld>
             <a:endParaRPr lang="en-US"/>
           </a:p>
@@ -1452,7 +1414,7 @@
           <a:p>
             <a:fld id="{F465A414-5ADB-4178-BBB9-F6D5CBEA4350}" type="datetimeFigureOut">
               <a:rPr lang="en-US" smtClean="0"/>
-              <a:t>7/2/2024</a:t>
+              <a:t>7/2/24</a:t>
             </a:fld>
             <a:endParaRPr lang="en-US"/>
           </a:p>
@@ -1864,7 +1826,7 @@
           <a:p>
             <a:fld id="{F465A414-5ADB-4178-BBB9-F6D5CBEA4350}" type="datetimeFigureOut">
               <a:rPr lang="en-US" smtClean="0"/>
-              <a:t>7/2/2024</a:t>
+              <a:t>7/2/24</a:t>
             </a:fld>
             <a:endParaRPr lang="en-US"/>
           </a:p>
@@ -2005,7 +1967,7 @@
           <a:p>
             <a:fld id="{F465A414-5ADB-4178-BBB9-F6D5CBEA4350}" type="datetimeFigureOut">
               <a:rPr lang="en-US" smtClean="0"/>
-              <a:t>7/2/2024</a:t>
+              <a:t>7/2/24</a:t>
             </a:fld>
             <a:endParaRPr lang="en-US"/>
           </a:p>
@@ -2118,7 +2080,7 @@
           <a:p>
             <a:fld id="{F465A414-5ADB-4178-BBB9-F6D5CBEA4350}" type="datetimeFigureOut">
               <a:rPr lang="en-US" smtClean="0"/>
-              <a:t>7/2/2024</a:t>
+              <a:t>7/2/24</a:t>
             </a:fld>
             <a:endParaRPr lang="en-US"/>
           </a:p>
@@ -2429,7 +2391,7 @@
           <a:p>
             <a:fld id="{F465A414-5ADB-4178-BBB9-F6D5CBEA4350}" type="datetimeFigureOut">
               <a:rPr lang="en-US" smtClean="0"/>
-              <a:t>7/2/2024</a:t>
+              <a:t>7/2/24</a:t>
             </a:fld>
             <a:endParaRPr lang="en-US"/>
           </a:p>
@@ -2720,7 +2682,7 @@
           <a:p>
             <a:fld id="{F465A414-5ADB-4178-BBB9-F6D5CBEA4350}" type="datetimeFigureOut">
               <a:rPr lang="en-US" smtClean="0"/>
-              <a:t>7/2/2024</a:t>
+              <a:t>7/2/24</a:t>
             </a:fld>
             <a:endParaRPr lang="en-US"/>
           </a:p>
@@ -2961,7 +2923,7 @@
           <a:p>
             <a:fld id="{F465A414-5ADB-4178-BBB9-F6D5CBEA4350}" type="datetimeFigureOut">
               <a:rPr lang="en-US" smtClean="0"/>
-              <a:t>7/2/2024</a:t>
+              <a:t>7/2/24</a:t>
             </a:fld>
             <a:endParaRPr lang="en-US"/>
           </a:p>
@@ -3787,7 +3749,7 @@
 
 <file path=ppt/webextensions/taskpanes.xml><?xml version="1.0" encoding="utf-8"?>
 <wetp:taskpanes xmlns:wetp="http://schemas.microsoft.com/office/webextensions/taskpanes/2010/11">
-  <wetp:taskpane dockstate="right" visibility="0" width="525" row="2">
+  <wetp:taskpane dockstate="right" visibility="0" width="350" row="2">
     <wetp:webextensionref xmlns:r="http://schemas.openxmlformats.org/officeDocument/2006/relationships" r:id="rId1"/>
   </wetp:taskpane>
 </wetp:taskpanes>

</xml_diff>